<commit_message>
Pitch: ledger and restart-safety on the AGH slide
</commit_message>
<xml_diff>
--- a/docs/silicon-agent-pitch.pptx
+++ b/docs/silicon-agent-pitch.pptx
@@ -15003,7 +15003,39 @@
                 </a:solidFill>
                 <a:latin typeface="PingFang SC"/>
               </a:rPr>
-              <a:t>一个对话 = 一个 AGH 会话；前端显示的「智能体过程」就是 AGH 的工具账本。</a:t>
+              <a:t>一个对话 = 一个 AGH 会话；前端显示的「智能体过程」就是 AGH 的工具账本，每轮回复下面是它的费用账本（模型调用次数、token、估算美元、用时）。</a:t>
+            </a:r>
+          </a:p>
+          <a:p>
+            <a:pPr algn="l">
+              <a:lnSpc>
+                <a:spcPct val="115000"/>
+              </a:lnSpc>
+            </a:pPr>
+            <a:r>
+              <a:rPr sz="1300" b="0">
+                <a:solidFill>
+                  <a:srgbClr val="A9A89F"/>
+                </a:solidFill>
+                <a:latin typeface="PingFang SC"/>
+              </a:rPr>
+              <a:t/>
+            </a:r>
+          </a:p>
+          <a:p>
+            <a:pPr algn="l">
+              <a:lnSpc>
+                <a:spcPct val="115000"/>
+              </a:lnSpc>
+            </a:pPr>
+            <a:r>
+              <a:rPr sz="1300" b="0">
+                <a:solidFill>
+                  <a:srgbClr val="A9A89F"/>
+                </a:solidFill>
+                <a:latin typeface="PingFang SC"/>
+              </a:rPr>
+              <a:t>作业服务器重启不丢轮次：从 AGH 的会话投影重建这一轮，或让智能体按自己的记录续接。</a:t>
             </a:r>
           </a:p>
         </p:txBody>

</xml_diff>

<commit_message>
Pitch: the knob the agent asked for
</commit_message>
<xml_diff>
--- a/docs/silicon-agent-pitch.pptx
+++ b/docs/silicon-agent-pitch.pptx
@@ -15384,6 +15384,38 @@
                 <a:latin typeface="PingFang SC"/>
               </a:rPr>
               <a:t>agent 自己发现过一个仿真库 bug（Gowin ALU 模型常量输入下永远 X），修掉后它重跑收敛到 236 LUT。</a:t>
+            </a:r>
+          </a:p>
+          <a:p>
+            <a:pPr algn="l">
+              <a:lnSpc>
+                <a:spcPct val="115000"/>
+              </a:lnSpc>
+            </a:pPr>
+            <a:r>
+              <a:rPr sz="1300" b="0">
+                <a:solidFill>
+                  <a:srgbClr val="A9A89F"/>
+                </a:solidFill>
+                <a:latin typeface="PingFang SC"/>
+              </a:rPr>
+              <a:t/>
+            </a:r>
+          </a:p>
+          <a:p>
+            <a:pPr algn="l">
+              <a:lnSpc>
+                <a:spcPct val="115000"/>
+              </a:lnSpc>
+            </a:pPr>
+            <a:r>
+              <a:rPr sz="1300" b="0">
+                <a:solidFill>
+                  <a:srgbClr val="34C759"/>
+                </a:solidFill>
+                <a:latin typeface="PingFang SC"/>
+              </a:rPr>
+              <a:t>深思模式（V4 Pro + thinking）从关键路径推出「生成器缺一个旋钮」——做成 sum_tree 后 iCE40 FIR 49.5→55.0 MHz，形式验证通过。</a:t>
             </a:r>
           </a:p>
         </p:txBody>

</xml_diff>

<commit_message>
Pitch: versatility slide, roadmap and close updated
</commit_message>
<xml_diff>
--- a/docs/silicon-agent-pitch.pptx
+++ b/docs/silicon-agent-pitch.pptx
@@ -22,6 +22,7 @@
     <p:sldId id="270" r:id="rId21"/>
     <p:sldId id="271" r:id="rId22"/>
     <p:sldId id="272" r:id="rId23"/>
+    <p:sldId id="273" r:id="rId24"/>
   </p:sldIdLst>
   <p:sldSz cx="12191695" cy="6858000" type="screen4x3"/>
   <p:notesSz cx="6858000" cy="9144000"/>
@@ -11933,7 +11934,7 @@
                 </a:solidFill>
                 <a:latin typeface="Menlo"/>
               </a:rPr>
-              <a:t>13 · 路线图</a:t>
+              <a:t>12b · 扩展</a:t>
             </a:r>
           </a:p>
         </p:txBody>
@@ -11972,7 +11973,7 @@
                 </a:solidFill>
                 <a:latin typeface="PingFang SC"/>
               </a:rPr>
-              <a:t>路线图：本周做完的，和下一步</a:t>
+              <a:t>更 versatile：智能体改自己的生成器、用户自带 RTL、ASIC 标准单元</a:t>
             </a:r>
           </a:p>
         </p:txBody>
@@ -12064,7 +12065,7 @@
         <p:spPr>
           <a:xfrm>
             <a:off x="640080" y="1645920"/>
-            <a:ext cx="3566160" cy="4572000"/>
+            <a:ext cx="3566160" cy="4206240"/>
           </a:xfrm>
           <a:prstGeom prst="roundRect">
             <a:avLst>
@@ -12105,216 +12106,156 @@
       </p:sp>
       <p:sp>
         <p:nvSpPr>
-          <p:cNvPr id="7" name="Rectangle 6"/>
+          <p:cNvPr id="7" name="TextBox 6"/>
+          <p:cNvSpPr txBox="1"/>
+          <p:nvPr/>
+        </p:nvSpPr>
+        <p:spPr>
+          <a:xfrm>
+            <a:off x="841248" y="1810512"/>
+            <a:ext cx="3163824" cy="365760"/>
+          </a:xfrm>
+          <a:prstGeom prst="rect">
+            <a:avLst/>
+          </a:prstGeom>
+          <a:noFill/>
+        </p:spPr>
+        <p:txBody>
+          <a:bodyPr wrap="square" anchor="t" lIns="0" rIns="0" tIns="0" bIns="0">
+            <a:spAutoFit/>
+          </a:bodyPr>
+          <a:lstStyle/>
+          <a:p>
+            <a:pPr algn="l">
+              <a:lnSpc>
+                <a:spcPct val="115000"/>
+              </a:lnSpc>
+            </a:pPr>
+            <a:r>
+              <a:rPr sz="1500" b="1">
+                <a:solidFill>
+                  <a:srgbClr val="ECECE6"/>
+                </a:solidFill>
+                <a:latin typeface="PingFang SC"/>
+              </a:rPr>
+              <a:t>智能体改生成器（author 模式）</a:t>
+            </a:r>
+          </a:p>
+        </p:txBody>
+      </p:sp>
+      <p:sp>
+        <p:nvSpPr>
+          <p:cNvPr id="8" name="TextBox 7"/>
+          <p:cNvSpPr txBox="1"/>
+          <p:nvPr/>
+        </p:nvSpPr>
+        <p:spPr>
+          <a:xfrm>
+            <a:off x="841248" y="2212848"/>
+            <a:ext cx="3163824" cy="3474720"/>
+          </a:xfrm>
+          <a:prstGeom prst="rect">
+            <a:avLst/>
+          </a:prstGeom>
+          <a:noFill/>
+        </p:spPr>
+        <p:txBody>
+          <a:bodyPr wrap="square" anchor="t" lIns="0" rIns="0" tIns="0" bIns="0">
+            <a:spAutoFit/>
+          </a:bodyPr>
+          <a:lstStyle/>
+          <a:p>
+            <a:pPr algn="l">
+              <a:lnSpc>
+                <a:spcPct val="115000"/>
+              </a:lnSpc>
+            </a:pPr>
+            <a:r>
+              <a:rPr sz="1300" b="0">
+                <a:solidFill>
+                  <a:srgbClr val="A9A89F"/>
+                </a:solidFill>
+                <a:latin typeface="PingFang SC"/>
+              </a:rPr>
+              <a:t>AGH 里一个独立会话（author 配方，可写/可执行）在 silicon_agent/ 的草稿副本上改代码，sa_check 用真实工具链试跑，sa_propose 提交 diff。</a:t>
+            </a:r>
+          </a:p>
+          <a:p>
+            <a:pPr algn="l">
+              <a:lnSpc>
+                <a:spcPct val="115000"/>
+              </a:lnSpc>
+            </a:pPr>
+            <a:r>
+              <a:rPr sz="1300" b="0">
+                <a:solidFill>
+                  <a:srgbClr val="A9A89F"/>
+                </a:solidFill>
+                <a:latin typeface="PingFang SC"/>
+              </a:rPr>
+              <a:t/>
+            </a:r>
+          </a:p>
+          <a:p>
+            <a:pPr algn="l">
+              <a:lnSpc>
+                <a:spcPct val="115000"/>
+              </a:lnSpc>
+            </a:pPr>
+            <a:r>
+              <a:rPr sz="1300" b="0">
+                <a:solidFill>
+                  <a:srgbClr val="A9A89F"/>
+                </a:solidFill>
+                <a:latin typeface="PingFang SC"/>
+              </a:rPr>
+              <a:t>作业服务器门禁：所有预设可发射/展开、bench 用例行为仿真、未改 IR 形式等价、测试台变异分数不降、再在改过的生成器上实跑 A/B。</a:t>
+            </a:r>
+          </a:p>
+          <a:p>
+            <a:pPr algn="l">
+              <a:lnSpc>
+                <a:spcPct val="115000"/>
+              </a:lnSpc>
+            </a:pPr>
+            <a:r>
+              <a:rPr sz="1300" b="0">
+                <a:solidFill>
+                  <a:srgbClr val="A9A89F"/>
+                </a:solidFill>
+                <a:latin typeface="PingFang SC"/>
+              </a:rPr>
+              <a:t/>
+            </a:r>
+          </a:p>
+          <a:p>
+            <a:pPr algn="l">
+              <a:lnSpc>
+                <a:spcPct val="115000"/>
+              </a:lnSpc>
+            </a:pPr>
+            <a:r>
+              <a:rPr sz="1300" b="0">
+                <a:solidFill>
+                  <a:srgbClr val="34C759"/>
+                </a:solidFill>
+                <a:latin typeface="PingFang SC"/>
+              </a:rPr>
+              <a:t>第一个提案：智能体给 CORDIC 加了 reg_out 旋钮，门禁 4/4 通过，A/B 实测 202 MHz。合并仍由人决定。</a:t>
+            </a:r>
+          </a:p>
+        </p:txBody>
+      </p:sp>
+      <p:sp>
+        <p:nvSpPr>
+          <p:cNvPr id="9" name="Rounded Rectangle 8"/>
           <p:cNvSpPr/>
           <p:nvPr/>
         </p:nvSpPr>
         <p:spPr>
           <a:xfrm>
-            <a:off x="640080" y="1645920"/>
-            <a:ext cx="3566160" cy="73152"/>
-          </a:xfrm>
-          <a:prstGeom prst="rect">
-            <a:avLst/>
-          </a:prstGeom>
-          <a:solidFill>
-            <a:srgbClr val="34C759"/>
-          </a:solidFill>
-          <a:ln>
-            <a:noFill/>
-          </a:ln>
-          <a:effectLst/>
-        </p:spPr>
-        <p:style>
-          <a:lnRef idx="1">
-            <a:schemeClr val="accent1"/>
-          </a:lnRef>
-          <a:fillRef idx="3">
-            <a:schemeClr val="accent1"/>
-          </a:fillRef>
-          <a:effectRef idx="2">
-            <a:schemeClr val="accent1"/>
-          </a:effectRef>
-          <a:fontRef idx="minor">
-            <a:schemeClr val="lt1"/>
-          </a:fontRef>
-        </p:style>
-        <p:txBody>
-          <a:bodyPr rtlCol="0" anchor="ctr" lIns="0" rIns="0"/>
-          <a:lstStyle/>
-          <a:p>
-            <a:pPr algn="ctr"/>
-          </a:p>
-        </p:txBody>
-      </p:sp>
-      <p:sp>
-        <p:nvSpPr>
-          <p:cNvPr id="8" name="TextBox 7"/>
-          <p:cNvSpPr txBox="1"/>
-          <p:nvPr/>
-        </p:nvSpPr>
-        <p:spPr>
-          <a:xfrm>
-            <a:off x="841248" y="1874519"/>
-            <a:ext cx="3200400" cy="365760"/>
-          </a:xfrm>
-          <a:prstGeom prst="rect">
-            <a:avLst/>
-          </a:prstGeom>
-          <a:noFill/>
-        </p:spPr>
-        <p:txBody>
-          <a:bodyPr wrap="square" anchor="t" lIns="0" rIns="0" tIns="0" bIns="0">
-            <a:spAutoFit/>
-          </a:bodyPr>
-          <a:lstStyle/>
-          <a:p>
-            <a:pPr algn="l">
-              <a:lnSpc>
-                <a:spcPct val="115000"/>
-              </a:lnSpc>
-            </a:pPr>
-            <a:r>
-              <a:rPr sz="1400" b="1">
-                <a:solidFill>
-                  <a:srgbClr val="34C759"/>
-                </a:solidFill>
-                <a:latin typeface="PingFang SC"/>
-              </a:rPr>
-              <a:t>已完成（本周）</a:t>
-            </a:r>
-          </a:p>
-        </p:txBody>
-      </p:sp>
-      <p:sp>
-        <p:nvSpPr>
-          <p:cNvPr id="9" name="TextBox 8"/>
-          <p:cNvSpPr txBox="1"/>
-          <p:nvPr/>
-        </p:nvSpPr>
-        <p:spPr>
-          <a:xfrm>
-            <a:off x="841248" y="2331720"/>
-            <a:ext cx="3200400" cy="3840480"/>
-          </a:xfrm>
-          <a:prstGeom prst="rect">
-            <a:avLst/>
-          </a:prstGeom>
-          <a:noFill/>
-        </p:spPr>
-        <p:txBody>
-          <a:bodyPr wrap="square" anchor="t" lIns="0" rIns="0" tIns="0" bIns="0">
-            <a:spAutoFit/>
-          </a:bodyPr>
-          <a:lstStyle/>
-          <a:p>
-            <a:pPr algn="l">
-              <a:lnSpc>
-                <a:spcPct val="130000"/>
-              </a:lnSpc>
-            </a:pPr>
-            <a:r>
-              <a:rPr sz="1150" b="0">
-                <a:solidFill>
-                  <a:srgbClr val="A9A89F"/>
-                </a:solidFill>
-                <a:latin typeface="PingFang SC"/>
-              </a:rPr>
-              <a:t>✓ 5 种器件插件：ECP5 / Spartan-7 / iCE40 / Gowin / GateMate</a:t>
-            </a:r>
-          </a:p>
-          <a:p>
-            <a:pPr algn="l">
-              <a:lnSpc>
-                <a:spcPct val="130000"/>
-              </a:lnSpc>
-            </a:pPr>
-            <a:r>
-              <a:rPr sz="1150" b="0">
-                <a:solidFill>
-                  <a:srgbClr val="A9A89F"/>
-                </a:solidFill>
-                <a:latin typeface="PingFang SC"/>
-              </a:rPr>
-              <a:t>✓ 7 类生成器：matmul、FIR(+系数端口)、conv2d、FIR 级联、CORDIC、FFT、通用 IR 图</a:t>
-            </a:r>
-          </a:p>
-          <a:p>
-            <a:pPr algn="l">
-              <a:lnSpc>
-                <a:spcPct val="130000"/>
-              </a:lnSpc>
-            </a:pPr>
-            <a:r>
-              <a:rPr sz="1150" b="0">
-                <a:solidFill>
-                  <a:srgbClr val="A9A89F"/>
-                </a:solidFill>
-                <a:latin typeface="PingFang SC"/>
-              </a:rPr>
-              <a:t>✓ 并行候选评估 + kNN 校准估算（Gowin Fmax 误差 53%→13%）</a:t>
-            </a:r>
-          </a:p>
-          <a:p>
-            <a:pPr algn="l">
-              <a:lnSpc>
-                <a:spcPct val="130000"/>
-              </a:lnSpc>
-            </a:pPr>
-            <a:r>
-              <a:rPr sz="1150" b="0">
-                <a:solidFill>
-                  <a:srgbClr val="A9A89F"/>
-                </a:solidFill>
-                <a:latin typeface="PingFang SC"/>
-              </a:rPr>
-              <a:t>✓ 形式等价 + 覆盖率 + 每晚回归告警 + 多种子 Fmax</a:t>
-            </a:r>
-          </a:p>
-          <a:p>
-            <a:pPr algn="l">
-              <a:lnSpc>
-                <a:spcPct val="130000"/>
-              </a:lnSpc>
-            </a:pPr>
-            <a:r>
-              <a:rPr sz="1150" b="0">
-                <a:solidFill>
-                  <a:srgbClr val="A9A89F"/>
-                </a:solidFill>
-                <a:latin typeface="PingFang SC"/>
-              </a:rPr>
-              <a:t>✓ 交付包含板级工程；规划器多模型 A/B 开关</a:t>
-            </a:r>
-          </a:p>
-          <a:p>
-            <a:pPr algn="l">
-              <a:lnSpc>
-                <a:spcPct val="130000"/>
-              </a:lnSpc>
-            </a:pPr>
-            <a:r>
-              <a:rPr sz="1150" b="0">
-                <a:solidFill>
-                  <a:srgbClr val="A9A89F"/>
-                </a:solidFill>
-                <a:latin typeface="PingFang SC"/>
-              </a:rPr>
-              <a:t>✓ 聊天：ETA、架构替代方案一键追问、会话隔离</a:t>
-            </a:r>
-          </a:p>
-        </p:txBody>
-      </p:sp>
-      <p:sp>
-        <p:nvSpPr>
-          <p:cNvPr id="10" name="Rounded Rectangle 9"/>
-          <p:cNvSpPr/>
-          <p:nvPr/>
-        </p:nvSpPr>
-        <p:spPr>
-          <a:xfrm>
-            <a:off x="4389120" y="1645920"/>
-            <a:ext cx="3566160" cy="4572000"/>
+            <a:off x="4343400" y="1645920"/>
+            <a:ext cx="3566160" cy="4206240"/>
           </a:xfrm>
           <a:prstGeom prst="roundRect">
             <a:avLst>
@@ -12355,184 +12296,156 @@
       </p:sp>
       <p:sp>
         <p:nvSpPr>
-          <p:cNvPr id="11" name="Rectangle 10"/>
+          <p:cNvPr id="10" name="TextBox 9"/>
+          <p:cNvSpPr txBox="1"/>
+          <p:nvPr/>
+        </p:nvSpPr>
+        <p:spPr>
+          <a:xfrm>
+            <a:off x="4544568" y="1810512"/>
+            <a:ext cx="3163824" cy="365760"/>
+          </a:xfrm>
+          <a:prstGeom prst="rect">
+            <a:avLst/>
+          </a:prstGeom>
+          <a:noFill/>
+        </p:spPr>
+        <p:txBody>
+          <a:bodyPr wrap="square" anchor="t" lIns="0" rIns="0" tIns="0" bIns="0">
+            <a:spAutoFit/>
+          </a:bodyPr>
+          <a:lstStyle/>
+          <a:p>
+            <a:pPr algn="l">
+              <a:lnSpc>
+                <a:spcPct val="115000"/>
+              </a:lnSpc>
+            </a:pPr>
+            <a:r>
+              <a:rPr sz="1500" b="1">
+                <a:solidFill>
+                  <a:srgbClr val="ECECE6"/>
+                </a:solidFill>
+                <a:latin typeface="PingFang SC"/>
+              </a:rPr>
+              <a:t>用户自带 RTL</a:t>
+            </a:r>
+          </a:p>
+        </p:txBody>
+      </p:sp>
+      <p:sp>
+        <p:nvSpPr>
+          <p:cNvPr id="11" name="TextBox 10"/>
+          <p:cNvSpPr txBox="1"/>
+          <p:nvPr/>
+        </p:nvSpPr>
+        <p:spPr>
+          <a:xfrm>
+            <a:off x="4544568" y="2212848"/>
+            <a:ext cx="3163824" cy="3474720"/>
+          </a:xfrm>
+          <a:prstGeom prst="rect">
+            <a:avLst/>
+          </a:prstGeom>
+          <a:noFill/>
+        </p:spPr>
+        <p:txBody>
+          <a:bodyPr wrap="square" anchor="t" lIns="0" rIns="0" tIns="0" bIns="0">
+            <a:spAutoFit/>
+          </a:bodyPr>
+          <a:lstStyle/>
+          <a:p>
+            <a:pPr algn="l">
+              <a:lnSpc>
+                <a:spcPct val="115000"/>
+              </a:lnSpc>
+            </a:pPr>
+            <a:r>
+              <a:rPr sz="1300" b="0">
+                <a:solidFill>
+                  <a:srgbClr val="A9A89F"/>
+                </a:solidFill>
+                <a:latin typeface="PingFang SC"/>
+              </a:rPr>
+              <a:t>上传 SystemVerilog + 自检测试台 + 允许调的参数，注册成 rtl:&lt;id&gt;；同一条阶梯：用户的台跑行为级和每一级网表，综合、布局布线、形式属性。</a:t>
+            </a:r>
+          </a:p>
+          <a:p>
+            <a:pPr algn="l">
+              <a:lnSpc>
+                <a:spcPct val="115000"/>
+              </a:lnSpc>
+            </a:pPr>
+            <a:r>
+              <a:rPr sz="1300" b="0">
+                <a:solidFill>
+                  <a:srgbClr val="A9A89F"/>
+                </a:solidFill>
+                <a:latin typeface="PingFang SC"/>
+              </a:rPr>
+              <a:t/>
+            </a:r>
+          </a:p>
+          <a:p>
+            <a:pPr algn="l">
+              <a:lnSpc>
+                <a:spcPct val="115000"/>
+              </a:lnSpc>
+            </a:pPr>
+            <a:r>
+              <a:rPr sz="1300" b="0">
+                <a:solidFill>
+                  <a:srgbClr val="A9A89F"/>
+                </a:solidFill>
+                <a:latin typeface="PingFang SC"/>
+              </a:rPr>
+              <a:t>流水线改动用 transfer-level 等价（允许延迟偏移）证明两组参数功能相同。</a:t>
+            </a:r>
+          </a:p>
+          <a:p>
+            <a:pPr algn="l">
+              <a:lnSpc>
+                <a:spcPct val="115000"/>
+              </a:lnSpc>
+            </a:pPr>
+            <a:r>
+              <a:rPr sz="1300" b="0">
+                <a:solidFill>
+                  <a:srgbClr val="A9A89F"/>
+                </a:solidFill>
+                <a:latin typeface="PingFang SC"/>
+              </a:rPr>
+              <a:t/>
+            </a:r>
+          </a:p>
+          <a:p>
+            <a:pPr algn="l">
+              <a:lnSpc>
+                <a:spcPct val="115000"/>
+              </a:lnSpc>
+            </a:pPr>
+            <a:r>
+              <a:rPr sz="1300" b="0">
+                <a:solidFill>
+                  <a:srgbClr val="34C759"/>
+                </a:solidFill>
+                <a:latin typeface="PingFang SC"/>
+              </a:rPr>
+              <a:t>聊天里一个 ＋ 按钮附加 .sv 文件，智能体自己写台、注册、跑。</a:t>
+            </a:r>
+          </a:p>
+        </p:txBody>
+      </p:sp>
+      <p:sp>
+        <p:nvSpPr>
+          <p:cNvPr id="12" name="Rounded Rectangle 11"/>
           <p:cNvSpPr/>
           <p:nvPr/>
         </p:nvSpPr>
         <p:spPr>
           <a:xfrm>
-            <a:off x="4389120" y="1645920"/>
-            <a:ext cx="3566160" cy="73152"/>
-          </a:xfrm>
-          <a:prstGeom prst="rect">
-            <a:avLst/>
-          </a:prstGeom>
-          <a:solidFill>
-            <a:srgbClr val="4A90E2"/>
-          </a:solidFill>
-          <a:ln>
-            <a:noFill/>
-          </a:ln>
-          <a:effectLst/>
-        </p:spPr>
-        <p:style>
-          <a:lnRef idx="1">
-            <a:schemeClr val="accent1"/>
-          </a:lnRef>
-          <a:fillRef idx="3">
-            <a:schemeClr val="accent1"/>
-          </a:fillRef>
-          <a:effectRef idx="2">
-            <a:schemeClr val="accent1"/>
-          </a:effectRef>
-          <a:fontRef idx="minor">
-            <a:schemeClr val="lt1"/>
-          </a:fontRef>
-        </p:style>
-        <p:txBody>
-          <a:bodyPr rtlCol="0" anchor="ctr" lIns="0" rIns="0"/>
-          <a:lstStyle/>
-          <a:p>
-            <a:pPr algn="ctr"/>
-          </a:p>
-        </p:txBody>
-      </p:sp>
-      <p:sp>
-        <p:nvSpPr>
-          <p:cNvPr id="12" name="TextBox 11"/>
-          <p:cNvSpPr txBox="1"/>
-          <p:nvPr/>
-        </p:nvSpPr>
-        <p:spPr>
-          <a:xfrm>
-            <a:off x="4590288" y="1874519"/>
-            <a:ext cx="3200400" cy="365760"/>
-          </a:xfrm>
-          <a:prstGeom prst="rect">
-            <a:avLst/>
-          </a:prstGeom>
-          <a:noFill/>
-        </p:spPr>
-        <p:txBody>
-          <a:bodyPr wrap="square" anchor="t" lIns="0" rIns="0" tIns="0" bIns="0">
-            <a:spAutoFit/>
-          </a:bodyPr>
-          <a:lstStyle/>
-          <a:p>
-            <a:pPr algn="l">
-              <a:lnSpc>
-                <a:spcPct val="115000"/>
-              </a:lnSpc>
-            </a:pPr>
-            <a:r>
-              <a:rPr sz="1400" b="1">
-                <a:solidFill>
-                  <a:srgbClr val="4A90E2"/>
-                </a:solidFill>
-                <a:latin typeface="PingFang SC"/>
-              </a:rPr>
-              <a:t>下一步 · 扩大空间</a:t>
-            </a:r>
-          </a:p>
-        </p:txBody>
-      </p:sp>
-      <p:sp>
-        <p:nvSpPr>
-          <p:cNvPr id="13" name="TextBox 12"/>
-          <p:cNvSpPr txBox="1"/>
-          <p:nvPr/>
-        </p:nvSpPr>
-        <p:spPr>
-          <a:xfrm>
-            <a:off x="4590288" y="2331720"/>
-            <a:ext cx="3200400" cy="3840480"/>
-          </a:xfrm>
-          <a:prstGeom prst="rect">
-            <a:avLst/>
-          </a:prstGeom>
-          <a:noFill/>
-        </p:spPr>
-        <p:txBody>
-          <a:bodyPr wrap="square" anchor="t" lIns="0" rIns="0" tIns="0" bIns="0">
-            <a:spAutoFit/>
-          </a:bodyPr>
-          <a:lstStyle/>
-          <a:p>
-            <a:pPr algn="l">
-              <a:lnSpc>
-                <a:spcPct val="130000"/>
-              </a:lnSpc>
-            </a:pPr>
-            <a:r>
-              <a:rPr sz="1150" b="0">
-                <a:solidFill>
-                  <a:srgbClr val="A9A89F"/>
-                </a:solidFill>
-                <a:latin typeface="PingFang SC"/>
-              </a:rPr>
-              <a:t>• Artix-7 / UltraScale+：装上 Vivado 器件文件即启用（后端已写好）</a:t>
-            </a:r>
-          </a:p>
-          <a:p>
-            <a:pPr algn="l">
-              <a:lnSpc>
-                <a:spcPct val="130000"/>
-              </a:lnSpc>
-            </a:pPr>
-            <a:r>
-              <a:rPr sz="1150" b="0">
-                <a:solidFill>
-                  <a:srgbClr val="A9A89F"/>
-                </a:solidFill>
-                <a:latin typeface="PingFang SC"/>
-              </a:rPr>
-              <a:t>• 更多节点：池化、滑窗 max、dot-product 折叠 matmul、CIC 抽取</a:t>
-            </a:r>
-          </a:p>
-          <a:p>
-            <a:pPr algn="l">
-              <a:lnSpc>
-                <a:spcPct val="130000"/>
-              </a:lnSpc>
-            </a:pPr>
-            <a:r>
-              <a:rPr sz="1150" b="0">
-                <a:solidFill>
-                  <a:srgbClr val="A9A89F"/>
-                </a:solidFill>
-                <a:latin typeface="PingFang SC"/>
-              </a:rPr>
-              <a:t>• 估算器上做贝叶斯优化：用 kNN 后验直接提候选，减少规划器调用</a:t>
-            </a:r>
-          </a:p>
-          <a:p>
-            <a:pPr algn="l">
-              <a:lnSpc>
-                <a:spcPct val="130000"/>
-              </a:lnSpc>
-            </a:pPr>
-            <a:r>
-              <a:rPr sz="1150" b="0">
-                <a:solidFill>
-                  <a:srgbClr val="A9A89F"/>
-                </a:solidFill>
-                <a:latin typeface="PingFang SC"/>
-              </a:rPr>
-              <a:t>• 多模型规划器基准对照（DeepSeek-reasoner / Claude / GPT）跑进每晚回归</a:t>
-            </a:r>
-          </a:p>
-        </p:txBody>
-      </p:sp>
-      <p:sp>
-        <p:nvSpPr>
-          <p:cNvPr id="14" name="Rounded Rectangle 13"/>
-          <p:cNvSpPr/>
-          <p:nvPr/>
-        </p:nvSpPr>
-        <p:spPr>
-          <a:xfrm>
-            <a:off x="8138159" y="1645920"/>
-            <a:ext cx="3566160" cy="4572000"/>
+            <a:off x="8046720" y="1645920"/>
+            <a:ext cx="3566160" cy="4206240"/>
           </a:xfrm>
           <a:prstGeom prst="roundRect">
             <a:avLst>
@@ -12573,170 +12486,181 @@
       </p:sp>
       <p:sp>
         <p:nvSpPr>
-          <p:cNvPr id="15" name="Rectangle 14"/>
-          <p:cNvSpPr/>
-          <p:nvPr/>
-        </p:nvSpPr>
-        <p:spPr>
-          <a:xfrm>
-            <a:off x="8138159" y="1645920"/>
-            <a:ext cx="3566160" cy="73152"/>
-          </a:xfrm>
-          <a:prstGeom prst="rect">
-            <a:avLst/>
-          </a:prstGeom>
-          <a:solidFill>
-            <a:srgbClr val="D9A21B"/>
-          </a:solidFill>
-          <a:ln>
-            <a:noFill/>
-          </a:ln>
-          <a:effectLst/>
-        </p:spPr>
-        <p:style>
-          <a:lnRef idx="1">
-            <a:schemeClr val="accent1"/>
-          </a:lnRef>
-          <a:fillRef idx="3">
-            <a:schemeClr val="accent1"/>
-          </a:fillRef>
-          <a:effectRef idx="2">
-            <a:schemeClr val="accent1"/>
-          </a:effectRef>
-          <a:fontRef idx="minor">
-            <a:schemeClr val="lt1"/>
-          </a:fontRef>
-        </p:style>
-        <p:txBody>
-          <a:bodyPr rtlCol="0" anchor="ctr" lIns="0" rIns="0"/>
-          <a:lstStyle/>
-          <a:p>
-            <a:pPr algn="ctr"/>
-          </a:p>
-        </p:txBody>
-      </p:sp>
-      <p:sp>
-        <p:nvSpPr>
-          <p:cNvPr id="16" name="TextBox 15"/>
-          <p:cNvSpPr txBox="1"/>
-          <p:nvPr/>
-        </p:nvSpPr>
-        <p:spPr>
-          <a:xfrm>
-            <a:off x="8339327" y="1874519"/>
-            <a:ext cx="3200400" cy="365760"/>
-          </a:xfrm>
-          <a:prstGeom prst="rect">
-            <a:avLst/>
-          </a:prstGeom>
-          <a:noFill/>
-        </p:spPr>
-        <p:txBody>
-          <a:bodyPr wrap="square" anchor="t" lIns="0" rIns="0" tIns="0" bIns="0">
-            <a:spAutoFit/>
-          </a:bodyPr>
-          <a:lstStyle/>
-          <a:p>
-            <a:pPr algn="l">
-              <a:lnSpc>
-                <a:spcPct val="115000"/>
-              </a:lnSpc>
-            </a:pPr>
-            <a:r>
-              <a:rPr sz="1400" b="1">
-                <a:solidFill>
-                  <a:srgbClr val="D9A21B"/>
-                </a:solidFill>
-                <a:latin typeface="PingFang SC"/>
-              </a:rPr>
-              <a:t>更远 · 平台化</a:t>
-            </a:r>
-          </a:p>
-        </p:txBody>
-      </p:sp>
-      <p:sp>
-        <p:nvSpPr>
-          <p:cNvPr id="17" name="TextBox 16"/>
-          <p:cNvSpPr txBox="1"/>
-          <p:nvPr/>
-        </p:nvSpPr>
-        <p:spPr>
-          <a:xfrm>
-            <a:off x="8339327" y="2331720"/>
-            <a:ext cx="3200400" cy="3840480"/>
-          </a:xfrm>
-          <a:prstGeom prst="rect">
-            <a:avLst/>
-          </a:prstGeom>
-          <a:noFill/>
-        </p:spPr>
-        <p:txBody>
-          <a:bodyPr wrap="square" anchor="t" lIns="0" rIns="0" tIns="0" bIns="0">
-            <a:spAutoFit/>
-          </a:bodyPr>
-          <a:lstStyle/>
-          <a:p>
-            <a:pPr algn="l">
-              <a:lnSpc>
-                <a:spcPct val="130000"/>
-              </a:lnSpc>
-            </a:pPr>
-            <a:r>
-              <a:rPr sz="1150" b="0">
+          <p:cNvPr id="13" name="TextBox 12"/>
+          <p:cNvSpPr txBox="1"/>
+          <p:nvPr/>
+        </p:nvSpPr>
+        <p:spPr>
+          <a:xfrm>
+            <a:off x="8247888" y="1810512"/>
+            <a:ext cx="3163824" cy="365760"/>
+          </a:xfrm>
+          <a:prstGeom prst="rect">
+            <a:avLst/>
+          </a:prstGeom>
+          <a:noFill/>
+        </p:spPr>
+        <p:txBody>
+          <a:bodyPr wrap="square" anchor="t" lIns="0" rIns="0" tIns="0" bIns="0">
+            <a:spAutoFit/>
+          </a:bodyPr>
+          <a:lstStyle/>
+          <a:p>
+            <a:pPr algn="l">
+              <a:lnSpc>
+                <a:spcPct val="115000"/>
+              </a:lnSpc>
+            </a:pPr>
+            <a:r>
+              <a:rPr sz="1500" b="1">
+                <a:solidFill>
+                  <a:srgbClr val="ECECE6"/>
+                </a:solidFill>
+                <a:latin typeface="PingFang SC"/>
+              </a:rPr>
+              <a:t>ASIC：sky130 + OpenROAD</a:t>
+            </a:r>
+          </a:p>
+        </p:txBody>
+      </p:sp>
+      <p:sp>
+        <p:nvSpPr>
+          <p:cNvPr id="14" name="TextBox 13"/>
+          <p:cNvSpPr txBox="1"/>
+          <p:nvPr/>
+        </p:nvSpPr>
+        <p:spPr>
+          <a:xfrm>
+            <a:off x="8247888" y="2212848"/>
+            <a:ext cx="3163824" cy="3474720"/>
+          </a:xfrm>
+          <a:prstGeom prst="rect">
+            <a:avLst/>
+          </a:prstGeom>
+          <a:noFill/>
+        </p:spPr>
+        <p:txBody>
+          <a:bodyPr wrap="square" anchor="t" lIns="0" rIns="0" tIns="0" bIns="0">
+            <a:spAutoFit/>
+          </a:bodyPr>
+          <a:lstStyle/>
+          <a:p>
+            <a:pPr algn="l">
+              <a:lnSpc>
+                <a:spcPct val="115000"/>
+              </a:lnSpc>
+            </a:pPr>
+            <a:r>
+              <a:rPr sz="1300" b="0">
                 <a:solidFill>
                   <a:srgbClr val="A9A89F"/>
                 </a:solidFill>
                 <a:latin typeface="PingFang SC"/>
               </a:rPr>
-              <a:t>• 有板后：ILA/VIO 在板验证作为第六级</a:t>
-            </a:r>
-          </a:p>
-          <a:p>
-            <a:pPr algn="l">
-              <a:lnSpc>
-                <a:spcPct val="130000"/>
-              </a:lnSpc>
-            </a:pPr>
-            <a:r>
-              <a:rPr sz="1150" b="0">
+              <a:t>OpenROAD-flow-scripts 跑在独立容器里，队列目录耦合；指标变成标准单元数、面积 µm²、功耗、STA 关键路径（fa_1/ha_1 进位链）。</a:t>
+            </a:r>
+          </a:p>
+          <a:p>
+            <a:pPr algn="l">
+              <a:lnSpc>
+                <a:spcPct val="115000"/>
+              </a:lnSpc>
+            </a:pPr>
+            <a:r>
+              <a:rPr sz="1300" b="0">
                 <a:solidFill>
                   <a:srgbClr val="A9A89F"/>
                 </a:solidFill>
                 <a:latin typeface="PingFang SC"/>
               </a:rPr>
-              <a:t>• 开放 IR 规范（/schema 已导出），让外部生成器接入；设计记忆跨用户共享（可审计）</a:t>
-            </a:r>
-          </a:p>
-          <a:p>
-            <a:pPr algn="l">
-              <a:lnSpc>
-                <a:spcPct val="130000"/>
-              </a:lnSpc>
-            </a:pPr>
-            <a:r>
-              <a:rPr sz="1150" b="0">
+              <a:t/>
+            </a:r>
+          </a:p>
+          <a:p>
+            <a:pPr algn="l">
+              <a:lnSpc>
+                <a:spcPct val="115000"/>
+              </a:lnSpc>
+            </a:pPr>
+            <a:r>
+              <a:rPr sz="1300" b="0">
                 <a:solidFill>
                   <a:srgbClr val="A9A89F"/>
                 </a:solidFill>
                 <a:latin typeface="PingFang SC"/>
               </a:rPr>
-              <a:t>• 形式等价扩展到跨 IR（折叠 vs 展开同一滤波器）</a:t>
-            </a:r>
-          </a:p>
-          <a:p>
-            <a:pPr algn="l">
-              <a:lnSpc>
-                <a:spcPct val="130000"/>
-              </a:lnSpc>
-            </a:pPr>
-            <a:r>
-              <a:rPr sz="1150" b="0">
+              <a:t>综合后与布线后网表都用 sky130_fd_sc_hd 功能模型跑向量台；交付包含 GDS。</a:t>
+            </a:r>
+          </a:p>
+          <a:p>
+            <a:pPr algn="l">
+              <a:lnSpc>
+                <a:spcPct val="115000"/>
+              </a:lnSpc>
+            </a:pPr>
+            <a:r>
+              <a:rPr sz="1300" b="0">
                 <a:solidFill>
                   <a:srgbClr val="A9A89F"/>
                 </a:solidFill>
                 <a:latin typeface="PingFang SC"/>
               </a:rPr>
-              <a:t>• 从 SDF 时序仿真到门级功耗估计</a:t>
+              <a:t/>
+            </a:r>
+          </a:p>
+          <a:p>
+            <a:pPr algn="l">
+              <a:lnSpc>
+                <a:spcPct val="115000"/>
+              </a:lnSpc>
+            </a:pPr>
+            <a:r>
+              <a:rPr sz="1300" b="0">
+                <a:solidFill>
+                  <a:srgbClr val="34C759"/>
+                </a:solidFill>
+                <a:latin typeface="PingFang SC"/>
+              </a:rPr>
+              <a:t>首个实测：16 阶 FIR 207.8 MHz、1833 单元、22.2k µm²、7.4 mW，规划器自己从 3698 单元收敛到 1833。</a:t>
+            </a:r>
+          </a:p>
+        </p:txBody>
+      </p:sp>
+      <p:sp>
+        <p:nvSpPr>
+          <p:cNvPr id="15" name="TextBox 14"/>
+          <p:cNvSpPr txBox="1"/>
+          <p:nvPr/>
+        </p:nvSpPr>
+        <p:spPr>
+          <a:xfrm>
+            <a:off x="640080" y="6035040"/>
+            <a:ext cx="10972800" cy="457200"/>
+          </a:xfrm>
+          <a:prstGeom prst="rect">
+            <a:avLst/>
+          </a:prstGeom>
+          <a:noFill/>
+        </p:spPr>
+        <p:txBody>
+          <a:bodyPr wrap="square" anchor="t" lIns="0" rIns="0" tIns="0" bIns="0">
+            <a:spAutoFit/>
+          </a:bodyPr>
+          <a:lstStyle/>
+          <a:p>
+            <a:pPr algn="l">
+              <a:lnSpc>
+                <a:spcPct val="115000"/>
+              </a:lnSpc>
+            </a:pPr>
+            <a:r>
+              <a:rPr sz="1250" b="0">
+                <a:solidFill>
+                  <a:srgbClr val="A9A89F"/>
+                </a:solidFill>
+                <a:latin typeface="PingFang SC"/>
+              </a:rPr>
+              <a:t>同一轮还加了：decim / nco / iir 三个生成器（DDC = nco→decim→fir 一张图）、GP 代理模型排序候选、设计空间扫描卡、每次运行的变异分数、MCP 服务器。</a:t>
             </a:r>
           </a:p>
         </p:txBody>
@@ -12775,6 +12699,874 @@
         </p:nvSpPr>
         <p:spPr>
           <a:xfrm>
+            <a:off x="640080" y="411480"/>
+            <a:ext cx="7315200" cy="274320"/>
+          </a:xfrm>
+          <a:prstGeom prst="rect">
+            <a:avLst/>
+          </a:prstGeom>
+          <a:noFill/>
+        </p:spPr>
+        <p:txBody>
+          <a:bodyPr wrap="square" anchor="t" lIns="0" rIns="0" tIns="0" bIns="0">
+            <a:spAutoFit/>
+          </a:bodyPr>
+          <a:lstStyle/>
+          <a:p>
+            <a:pPr algn="l">
+              <a:lnSpc>
+                <a:spcPct val="115000"/>
+              </a:lnSpc>
+            </a:pPr>
+            <a:r>
+              <a:rPr sz="1200" b="1">
+                <a:solidFill>
+                  <a:srgbClr val="4A90E2"/>
+                </a:solidFill>
+                <a:latin typeface="Menlo"/>
+              </a:rPr>
+              <a:t>13 · 路线图</a:t>
+            </a:r>
+          </a:p>
+        </p:txBody>
+      </p:sp>
+      <p:sp>
+        <p:nvSpPr>
+          <p:cNvPr id="3" name="TextBox 2"/>
+          <p:cNvSpPr txBox="1"/>
+          <p:nvPr/>
+        </p:nvSpPr>
+        <p:spPr>
+          <a:xfrm>
+            <a:off x="640080" y="685800"/>
+            <a:ext cx="10515600" cy="731520"/>
+          </a:xfrm>
+          <a:prstGeom prst="rect">
+            <a:avLst/>
+          </a:prstGeom>
+          <a:noFill/>
+        </p:spPr>
+        <p:txBody>
+          <a:bodyPr wrap="square" anchor="t" lIns="0" rIns="0" tIns="0" bIns="0">
+            <a:spAutoFit/>
+          </a:bodyPr>
+          <a:lstStyle/>
+          <a:p>
+            <a:pPr algn="l">
+              <a:lnSpc>
+                <a:spcPct val="115000"/>
+              </a:lnSpc>
+            </a:pPr>
+            <a:r>
+              <a:rPr sz="3000" b="1">
+                <a:solidFill>
+                  <a:srgbClr val="ECECE6"/>
+                </a:solidFill>
+                <a:latin typeface="PingFang SC"/>
+              </a:rPr>
+              <a:t>路线图：本周做完的，和下一步</a:t>
+            </a:r>
+          </a:p>
+        </p:txBody>
+      </p:sp>
+      <p:sp>
+        <p:nvSpPr>
+          <p:cNvPr id="4" name="TextBox 3"/>
+          <p:cNvSpPr txBox="1"/>
+          <p:nvPr/>
+        </p:nvSpPr>
+        <p:spPr>
+          <a:xfrm>
+            <a:off x="11002975" y="6400800"/>
+            <a:ext cx="548640" cy="274320"/>
+          </a:xfrm>
+          <a:prstGeom prst="rect">
+            <a:avLst/>
+          </a:prstGeom>
+          <a:noFill/>
+        </p:spPr>
+        <p:txBody>
+          <a:bodyPr wrap="square" anchor="t" lIns="0" rIns="0" tIns="0" bIns="0">
+            <a:spAutoFit/>
+          </a:bodyPr>
+          <a:lstStyle/>
+          <a:p>
+            <a:pPr algn="r">
+              <a:lnSpc>
+                <a:spcPct val="115000"/>
+              </a:lnSpc>
+            </a:pPr>
+            <a:r>
+              <a:rPr sz="1000" b="0">
+                <a:solidFill>
+                  <a:srgbClr val="6F6E67"/>
+                </a:solidFill>
+                <a:latin typeface="Menlo"/>
+              </a:rPr>
+              <a:t>17</a:t>
+            </a:r>
+          </a:p>
+        </p:txBody>
+      </p:sp>
+      <p:sp>
+        <p:nvSpPr>
+          <p:cNvPr id="5" name="TextBox 4"/>
+          <p:cNvSpPr txBox="1"/>
+          <p:nvPr/>
+        </p:nvSpPr>
+        <p:spPr>
+          <a:xfrm>
+            <a:off x="640080" y="6400800"/>
+            <a:ext cx="2743200" cy="274320"/>
+          </a:xfrm>
+          <a:prstGeom prst="rect">
+            <a:avLst/>
+          </a:prstGeom>
+          <a:noFill/>
+        </p:spPr>
+        <p:txBody>
+          <a:bodyPr wrap="square" anchor="t" lIns="0" rIns="0" tIns="0" bIns="0">
+            <a:spAutoFit/>
+          </a:bodyPr>
+          <a:lstStyle/>
+          <a:p>
+            <a:pPr algn="l">
+              <a:lnSpc>
+                <a:spcPct val="115000"/>
+              </a:lnSpc>
+            </a:pPr>
+            <a:r>
+              <a:rPr sz="1000" b="0">
+                <a:solidFill>
+                  <a:srgbClr val="6F6E67"/>
+                </a:solidFill>
+                <a:latin typeface="Menlo"/>
+              </a:rPr>
+              <a:t>▣ silicon-agent</a:t>
+            </a:r>
+          </a:p>
+        </p:txBody>
+      </p:sp>
+      <p:sp>
+        <p:nvSpPr>
+          <p:cNvPr id="6" name="Rounded Rectangle 5"/>
+          <p:cNvSpPr/>
+          <p:nvPr/>
+        </p:nvSpPr>
+        <p:spPr>
+          <a:xfrm>
+            <a:off x="640080" y="1645920"/>
+            <a:ext cx="3566160" cy="4572000"/>
+          </a:xfrm>
+          <a:prstGeom prst="roundRect">
+            <a:avLst>
+              <a:gd name="adj" fmla="val 6000"/>
+            </a:avLst>
+          </a:prstGeom>
+          <a:solidFill>
+            <a:srgbClr val="1C1C1B"/>
+          </a:solidFill>
+          <a:ln w="9525">
+            <a:solidFill>
+              <a:srgbClr val="333331"/>
+            </a:solidFill>
+          </a:ln>
+          <a:effectLst/>
+        </p:spPr>
+        <p:style>
+          <a:lnRef idx="1">
+            <a:schemeClr val="accent1"/>
+          </a:lnRef>
+          <a:fillRef idx="3">
+            <a:schemeClr val="accent1"/>
+          </a:fillRef>
+          <a:effectRef idx="2">
+            <a:schemeClr val="accent1"/>
+          </a:effectRef>
+          <a:fontRef idx="minor">
+            <a:schemeClr val="lt1"/>
+          </a:fontRef>
+        </p:style>
+        <p:txBody>
+          <a:bodyPr rtlCol="0" anchor="ctr" lIns="0" rIns="0"/>
+          <a:lstStyle/>
+          <a:p>
+            <a:pPr algn="ctr"/>
+          </a:p>
+        </p:txBody>
+      </p:sp>
+      <p:sp>
+        <p:nvSpPr>
+          <p:cNvPr id="7" name="Rectangle 6"/>
+          <p:cNvSpPr/>
+          <p:nvPr/>
+        </p:nvSpPr>
+        <p:spPr>
+          <a:xfrm>
+            <a:off x="640080" y="1645920"/>
+            <a:ext cx="3566160" cy="73152"/>
+          </a:xfrm>
+          <a:prstGeom prst="rect">
+            <a:avLst/>
+          </a:prstGeom>
+          <a:solidFill>
+            <a:srgbClr val="34C759"/>
+          </a:solidFill>
+          <a:ln>
+            <a:noFill/>
+          </a:ln>
+          <a:effectLst/>
+        </p:spPr>
+        <p:style>
+          <a:lnRef idx="1">
+            <a:schemeClr val="accent1"/>
+          </a:lnRef>
+          <a:fillRef idx="3">
+            <a:schemeClr val="accent1"/>
+          </a:fillRef>
+          <a:effectRef idx="2">
+            <a:schemeClr val="accent1"/>
+          </a:effectRef>
+          <a:fontRef idx="minor">
+            <a:schemeClr val="lt1"/>
+          </a:fontRef>
+        </p:style>
+        <p:txBody>
+          <a:bodyPr rtlCol="0" anchor="ctr" lIns="0" rIns="0"/>
+          <a:lstStyle/>
+          <a:p>
+            <a:pPr algn="ctr"/>
+          </a:p>
+        </p:txBody>
+      </p:sp>
+      <p:sp>
+        <p:nvSpPr>
+          <p:cNvPr id="8" name="TextBox 7"/>
+          <p:cNvSpPr txBox="1"/>
+          <p:nvPr/>
+        </p:nvSpPr>
+        <p:spPr>
+          <a:xfrm>
+            <a:off x="841248" y="1874519"/>
+            <a:ext cx="3200400" cy="365760"/>
+          </a:xfrm>
+          <a:prstGeom prst="rect">
+            <a:avLst/>
+          </a:prstGeom>
+          <a:noFill/>
+        </p:spPr>
+        <p:txBody>
+          <a:bodyPr wrap="square" anchor="t" lIns="0" rIns="0" tIns="0" bIns="0">
+            <a:spAutoFit/>
+          </a:bodyPr>
+          <a:lstStyle/>
+          <a:p>
+            <a:pPr algn="l">
+              <a:lnSpc>
+                <a:spcPct val="115000"/>
+              </a:lnSpc>
+            </a:pPr>
+            <a:r>
+              <a:rPr sz="1400" b="1">
+                <a:solidFill>
+                  <a:srgbClr val="34C759"/>
+                </a:solidFill>
+                <a:latin typeface="PingFang SC"/>
+              </a:rPr>
+              <a:t>已完成</a:t>
+            </a:r>
+          </a:p>
+        </p:txBody>
+      </p:sp>
+      <p:sp>
+        <p:nvSpPr>
+          <p:cNvPr id="9" name="TextBox 8"/>
+          <p:cNvSpPr txBox="1"/>
+          <p:nvPr/>
+        </p:nvSpPr>
+        <p:spPr>
+          <a:xfrm>
+            <a:off x="841248" y="2331720"/>
+            <a:ext cx="3200400" cy="3840480"/>
+          </a:xfrm>
+          <a:prstGeom prst="rect">
+            <a:avLst/>
+          </a:prstGeom>
+          <a:noFill/>
+        </p:spPr>
+        <p:txBody>
+          <a:bodyPr wrap="square" anchor="t" lIns="0" rIns="0" tIns="0" bIns="0">
+            <a:spAutoFit/>
+          </a:bodyPr>
+          <a:lstStyle/>
+          <a:p>
+            <a:pPr algn="l">
+              <a:lnSpc>
+                <a:spcPct val="130000"/>
+              </a:lnSpc>
+            </a:pPr>
+            <a:r>
+              <a:rPr sz="1150" b="0">
+                <a:solidFill>
+                  <a:srgbClr val="A9A89F"/>
+                </a:solidFill>
+                <a:latin typeface="PingFang SC"/>
+              </a:rPr>
+              <a:t>✓ 6 种后端：ECP5 / Spartan-7 / iCE40 / Gowin / GateMate / sky130 ASIC</a:t>
+            </a:r>
+          </a:p>
+          <a:p>
+            <a:pPr algn="l">
+              <a:lnSpc>
+                <a:spcPct val="130000"/>
+              </a:lnSpc>
+            </a:pPr>
+            <a:r>
+              <a:rPr sz="1150" b="0">
+                <a:solidFill>
+                  <a:srgbClr val="A9A89F"/>
+                </a:solidFill>
+                <a:latin typeface="PingFang SC"/>
+              </a:rPr>
+              <a:t>✓ 10 类生成器 + 用户自带 RTL；DDC 级联一张图</a:t>
+            </a:r>
+          </a:p>
+          <a:p>
+            <a:pPr algn="l">
+              <a:lnSpc>
+                <a:spcPct val="130000"/>
+              </a:lnSpc>
+            </a:pPr>
+            <a:r>
+              <a:rPr sz="1150" b="0">
+                <a:solidFill>
+                  <a:srgbClr val="A9A89F"/>
+                </a:solidFill>
+                <a:latin typeface="PingFang SC"/>
+              </a:rPr>
+              <a:t>✓ 智能体改生成器：门禁（发射/仿真/形式等价/变异分数）+ A/B，人合并</a:t>
+            </a:r>
+          </a:p>
+          <a:p>
+            <a:pPr algn="l">
+              <a:lnSpc>
+                <a:spcPct val="130000"/>
+              </a:lnSpc>
+            </a:pPr>
+            <a:r>
+              <a:rPr sz="1150" b="0">
+                <a:solidFill>
+                  <a:srgbClr val="A9A89F"/>
+                </a:solidFill>
+                <a:latin typeface="PingFang SC"/>
+              </a:rPr>
+              <a:t>✓ GP 代理模型 + 设计空间扫描 + 每次运行变异分数</a:t>
+            </a:r>
+          </a:p>
+          <a:p>
+            <a:pPr algn="l">
+              <a:lnSpc>
+                <a:spcPct val="130000"/>
+              </a:lnSpc>
+            </a:pPr>
+            <a:r>
+              <a:rPr sz="1150" b="0">
+                <a:solidFill>
+                  <a:srgbClr val="A9A89F"/>
+                </a:solidFill>
+                <a:latin typeface="PingFang SC"/>
+              </a:rPr>
+              <a:t>✓ AGH 底座：快/深思/author 三种模式、账本、重启续接</a:t>
+            </a:r>
+          </a:p>
+          <a:p>
+            <a:pPr algn="l">
+              <a:lnSpc>
+                <a:spcPct val="130000"/>
+              </a:lnSpc>
+            </a:pPr>
+            <a:r>
+              <a:rPr sz="1150" b="0">
+                <a:solidFill>
+                  <a:srgbClr val="A9A89F"/>
+                </a:solidFill>
+                <a:latin typeface="PingFang SC"/>
+              </a:rPr>
+              <a:t>✓ MCP 服务器：Claude Code 直接调用</a:t>
+            </a:r>
+          </a:p>
+        </p:txBody>
+      </p:sp>
+      <p:sp>
+        <p:nvSpPr>
+          <p:cNvPr id="10" name="Rounded Rectangle 9"/>
+          <p:cNvSpPr/>
+          <p:nvPr/>
+        </p:nvSpPr>
+        <p:spPr>
+          <a:xfrm>
+            <a:off x="4389120" y="1645920"/>
+            <a:ext cx="3566160" cy="4572000"/>
+          </a:xfrm>
+          <a:prstGeom prst="roundRect">
+            <a:avLst>
+              <a:gd name="adj" fmla="val 6000"/>
+            </a:avLst>
+          </a:prstGeom>
+          <a:solidFill>
+            <a:srgbClr val="1C1C1B"/>
+          </a:solidFill>
+          <a:ln w="9525">
+            <a:solidFill>
+              <a:srgbClr val="333331"/>
+            </a:solidFill>
+          </a:ln>
+          <a:effectLst/>
+        </p:spPr>
+        <p:style>
+          <a:lnRef idx="1">
+            <a:schemeClr val="accent1"/>
+          </a:lnRef>
+          <a:fillRef idx="3">
+            <a:schemeClr val="accent1"/>
+          </a:fillRef>
+          <a:effectRef idx="2">
+            <a:schemeClr val="accent1"/>
+          </a:effectRef>
+          <a:fontRef idx="minor">
+            <a:schemeClr val="lt1"/>
+          </a:fontRef>
+        </p:style>
+        <p:txBody>
+          <a:bodyPr rtlCol="0" anchor="ctr" lIns="0" rIns="0"/>
+          <a:lstStyle/>
+          <a:p>
+            <a:pPr algn="ctr"/>
+          </a:p>
+        </p:txBody>
+      </p:sp>
+      <p:sp>
+        <p:nvSpPr>
+          <p:cNvPr id="11" name="Rectangle 10"/>
+          <p:cNvSpPr/>
+          <p:nvPr/>
+        </p:nvSpPr>
+        <p:spPr>
+          <a:xfrm>
+            <a:off x="4389120" y="1645920"/>
+            <a:ext cx="3566160" cy="73152"/>
+          </a:xfrm>
+          <a:prstGeom prst="rect">
+            <a:avLst/>
+          </a:prstGeom>
+          <a:solidFill>
+            <a:srgbClr val="4A90E2"/>
+          </a:solidFill>
+          <a:ln>
+            <a:noFill/>
+          </a:ln>
+          <a:effectLst/>
+        </p:spPr>
+        <p:style>
+          <a:lnRef idx="1">
+            <a:schemeClr val="accent1"/>
+          </a:lnRef>
+          <a:fillRef idx="3">
+            <a:schemeClr val="accent1"/>
+          </a:fillRef>
+          <a:effectRef idx="2">
+            <a:schemeClr val="accent1"/>
+          </a:effectRef>
+          <a:fontRef idx="minor">
+            <a:schemeClr val="lt1"/>
+          </a:fontRef>
+        </p:style>
+        <p:txBody>
+          <a:bodyPr rtlCol="0" anchor="ctr" lIns="0" rIns="0"/>
+          <a:lstStyle/>
+          <a:p>
+            <a:pPr algn="ctr"/>
+          </a:p>
+        </p:txBody>
+      </p:sp>
+      <p:sp>
+        <p:nvSpPr>
+          <p:cNvPr id="12" name="TextBox 11"/>
+          <p:cNvSpPr txBox="1"/>
+          <p:nvPr/>
+        </p:nvSpPr>
+        <p:spPr>
+          <a:xfrm>
+            <a:off x="4590288" y="1874519"/>
+            <a:ext cx="3200400" cy="365760"/>
+          </a:xfrm>
+          <a:prstGeom prst="rect">
+            <a:avLst/>
+          </a:prstGeom>
+          <a:noFill/>
+        </p:spPr>
+        <p:txBody>
+          <a:bodyPr wrap="square" anchor="t" lIns="0" rIns="0" tIns="0" bIns="0">
+            <a:spAutoFit/>
+          </a:bodyPr>
+          <a:lstStyle/>
+          <a:p>
+            <a:pPr algn="l">
+              <a:lnSpc>
+                <a:spcPct val="115000"/>
+              </a:lnSpc>
+            </a:pPr>
+            <a:r>
+              <a:rPr sz="1400" b="1">
+                <a:solidFill>
+                  <a:srgbClr val="4A90E2"/>
+                </a:solidFill>
+                <a:latin typeface="PingFang SC"/>
+              </a:rPr>
+              <a:t>下一步 · 扩大空间</a:t>
+            </a:r>
+          </a:p>
+        </p:txBody>
+      </p:sp>
+      <p:sp>
+        <p:nvSpPr>
+          <p:cNvPr id="13" name="TextBox 12"/>
+          <p:cNvSpPr txBox="1"/>
+          <p:nvPr/>
+        </p:nvSpPr>
+        <p:spPr>
+          <a:xfrm>
+            <a:off x="4590288" y="2331720"/>
+            <a:ext cx="3200400" cy="3840480"/>
+          </a:xfrm>
+          <a:prstGeom prst="rect">
+            <a:avLst/>
+          </a:prstGeom>
+          <a:noFill/>
+        </p:spPr>
+        <p:txBody>
+          <a:bodyPr wrap="square" anchor="t" lIns="0" rIns="0" tIns="0" bIns="0">
+            <a:spAutoFit/>
+          </a:bodyPr>
+          <a:lstStyle/>
+          <a:p>
+            <a:pPr algn="l">
+              <a:lnSpc>
+                <a:spcPct val="130000"/>
+              </a:lnSpc>
+            </a:pPr>
+            <a:r>
+              <a:rPr sz="1150" b="0">
+                <a:solidFill>
+                  <a:srgbClr val="A9A89F"/>
+                </a:solidFill>
+                <a:latin typeface="PingFang SC"/>
+              </a:rPr>
+              <a:t>• Artix-7 / UltraScale+：装上 Vivado 器件文件即启用</a:t>
+            </a:r>
+          </a:p>
+          <a:p>
+            <a:pPr algn="l">
+              <a:lnSpc>
+                <a:spcPct val="130000"/>
+              </a:lnSpc>
+            </a:pPr>
+            <a:r>
+              <a:rPr sz="1150" b="0">
+                <a:solidFill>
+                  <a:srgbClr val="A9A89F"/>
+                </a:solidFill>
+                <a:latin typeface="PingFang SC"/>
+              </a:rPr>
+              <a:t>• 让智能体写全新生成器：RTL 与参考模型分两个会话写、互相校验</a:t>
+            </a:r>
+          </a:p>
+          <a:p>
+            <a:pPr algn="l">
+              <a:lnSpc>
+                <a:spcPct val="130000"/>
+              </a:lnSpc>
+            </a:pPr>
+            <a:r>
+              <a:rPr sz="1150" b="0">
+                <a:solidFill>
+                  <a:srgbClr val="A9A89F"/>
+                </a:solidFill>
+                <a:latin typeface="PingFang SC"/>
+              </a:rPr>
+              <a:t>• 更多节点：CIC、池化、im2col+matmul 卷积层、CRC</a:t>
+            </a:r>
+          </a:p>
+          <a:p>
+            <a:pPr algn="l">
+              <a:lnSpc>
+                <a:spcPct val="130000"/>
+              </a:lnSpc>
+            </a:pPr>
+            <a:r>
+              <a:rPr sz="1150" b="0">
+                <a:solidFill>
+                  <a:srgbClr val="A9A89F"/>
+                </a:solidFill>
+                <a:latin typeface="PingFang SC"/>
+              </a:rPr>
+              <a:t>• 多模型规划器对照进每晚回归</a:t>
+            </a:r>
+          </a:p>
+        </p:txBody>
+      </p:sp>
+      <p:sp>
+        <p:nvSpPr>
+          <p:cNvPr id="14" name="Rounded Rectangle 13"/>
+          <p:cNvSpPr/>
+          <p:nvPr/>
+        </p:nvSpPr>
+        <p:spPr>
+          <a:xfrm>
+            <a:off x="8138159" y="1645920"/>
+            <a:ext cx="3566160" cy="4572000"/>
+          </a:xfrm>
+          <a:prstGeom prst="roundRect">
+            <a:avLst>
+              <a:gd name="adj" fmla="val 6000"/>
+            </a:avLst>
+          </a:prstGeom>
+          <a:solidFill>
+            <a:srgbClr val="1C1C1B"/>
+          </a:solidFill>
+          <a:ln w="9525">
+            <a:solidFill>
+              <a:srgbClr val="333331"/>
+            </a:solidFill>
+          </a:ln>
+          <a:effectLst/>
+        </p:spPr>
+        <p:style>
+          <a:lnRef idx="1">
+            <a:schemeClr val="accent1"/>
+          </a:lnRef>
+          <a:fillRef idx="3">
+            <a:schemeClr val="accent1"/>
+          </a:fillRef>
+          <a:effectRef idx="2">
+            <a:schemeClr val="accent1"/>
+          </a:effectRef>
+          <a:fontRef idx="minor">
+            <a:schemeClr val="lt1"/>
+          </a:fontRef>
+        </p:style>
+        <p:txBody>
+          <a:bodyPr rtlCol="0" anchor="ctr" lIns="0" rIns="0"/>
+          <a:lstStyle/>
+          <a:p>
+            <a:pPr algn="ctr"/>
+          </a:p>
+        </p:txBody>
+      </p:sp>
+      <p:sp>
+        <p:nvSpPr>
+          <p:cNvPr id="15" name="Rectangle 14"/>
+          <p:cNvSpPr/>
+          <p:nvPr/>
+        </p:nvSpPr>
+        <p:spPr>
+          <a:xfrm>
+            <a:off x="8138159" y="1645920"/>
+            <a:ext cx="3566160" cy="73152"/>
+          </a:xfrm>
+          <a:prstGeom prst="rect">
+            <a:avLst/>
+          </a:prstGeom>
+          <a:solidFill>
+            <a:srgbClr val="D9A21B"/>
+          </a:solidFill>
+          <a:ln>
+            <a:noFill/>
+          </a:ln>
+          <a:effectLst/>
+        </p:spPr>
+        <p:style>
+          <a:lnRef idx="1">
+            <a:schemeClr val="accent1"/>
+          </a:lnRef>
+          <a:fillRef idx="3">
+            <a:schemeClr val="accent1"/>
+          </a:fillRef>
+          <a:effectRef idx="2">
+            <a:schemeClr val="accent1"/>
+          </a:effectRef>
+          <a:fontRef idx="minor">
+            <a:schemeClr val="lt1"/>
+          </a:fontRef>
+        </p:style>
+        <p:txBody>
+          <a:bodyPr rtlCol="0" anchor="ctr" lIns="0" rIns="0"/>
+          <a:lstStyle/>
+          <a:p>
+            <a:pPr algn="ctr"/>
+          </a:p>
+        </p:txBody>
+      </p:sp>
+      <p:sp>
+        <p:nvSpPr>
+          <p:cNvPr id="16" name="TextBox 15"/>
+          <p:cNvSpPr txBox="1"/>
+          <p:nvPr/>
+        </p:nvSpPr>
+        <p:spPr>
+          <a:xfrm>
+            <a:off x="8339327" y="1874519"/>
+            <a:ext cx="3200400" cy="365760"/>
+          </a:xfrm>
+          <a:prstGeom prst="rect">
+            <a:avLst/>
+          </a:prstGeom>
+          <a:noFill/>
+        </p:spPr>
+        <p:txBody>
+          <a:bodyPr wrap="square" anchor="t" lIns="0" rIns="0" tIns="0" bIns="0">
+            <a:spAutoFit/>
+          </a:bodyPr>
+          <a:lstStyle/>
+          <a:p>
+            <a:pPr algn="l">
+              <a:lnSpc>
+                <a:spcPct val="115000"/>
+              </a:lnSpc>
+            </a:pPr>
+            <a:r>
+              <a:rPr sz="1400" b="1">
+                <a:solidFill>
+                  <a:srgbClr val="D9A21B"/>
+                </a:solidFill>
+                <a:latin typeface="PingFang SC"/>
+              </a:rPr>
+              <a:t>更远 · 平台化</a:t>
+            </a:r>
+          </a:p>
+        </p:txBody>
+      </p:sp>
+      <p:sp>
+        <p:nvSpPr>
+          <p:cNvPr id="17" name="TextBox 16"/>
+          <p:cNvSpPr txBox="1"/>
+          <p:nvPr/>
+        </p:nvSpPr>
+        <p:spPr>
+          <a:xfrm>
+            <a:off x="8339327" y="2331720"/>
+            <a:ext cx="3200400" cy="3840480"/>
+          </a:xfrm>
+          <a:prstGeom prst="rect">
+            <a:avLst/>
+          </a:prstGeom>
+          <a:noFill/>
+        </p:spPr>
+        <p:txBody>
+          <a:bodyPr wrap="square" anchor="t" lIns="0" rIns="0" tIns="0" bIns="0">
+            <a:spAutoFit/>
+          </a:bodyPr>
+          <a:lstStyle/>
+          <a:p>
+            <a:pPr algn="l">
+              <a:lnSpc>
+                <a:spcPct val="130000"/>
+              </a:lnSpc>
+            </a:pPr>
+            <a:r>
+              <a:rPr sz="1150" b="0">
+                <a:solidFill>
+                  <a:srgbClr val="A9A89F"/>
+                </a:solidFill>
+                <a:latin typeface="PingFang SC"/>
+              </a:rPr>
+              <a:t>• 有板后：ILA/VIO 在板验证作为第六级</a:t>
+            </a:r>
+          </a:p>
+          <a:p>
+            <a:pPr algn="l">
+              <a:lnSpc>
+                <a:spcPct val="130000"/>
+              </a:lnSpc>
+            </a:pPr>
+            <a:r>
+              <a:rPr sz="1150" b="0">
+                <a:solidFill>
+                  <a:srgbClr val="A9A89F"/>
+                </a:solidFill>
+                <a:latin typeface="PingFang SC"/>
+              </a:rPr>
+              <a:t>• 开放 IR 规范（/schema 已导出），让外部生成器接入；设计记忆跨用户共享（可审计）</a:t>
+            </a:r>
+          </a:p>
+          <a:p>
+            <a:pPr algn="l">
+              <a:lnSpc>
+                <a:spcPct val="130000"/>
+              </a:lnSpc>
+            </a:pPr>
+            <a:r>
+              <a:rPr sz="1150" b="0">
+                <a:solidFill>
+                  <a:srgbClr val="A9A89F"/>
+                </a:solidFill>
+                <a:latin typeface="PingFang SC"/>
+              </a:rPr>
+              <a:t>• 形式等价扩展到跨 IR（折叠 vs 展开同一滤波器）</a:t>
+            </a:r>
+          </a:p>
+          <a:p>
+            <a:pPr algn="l">
+              <a:lnSpc>
+                <a:spcPct val="130000"/>
+              </a:lnSpc>
+            </a:pPr>
+            <a:r>
+              <a:rPr sz="1150" b="0">
+                <a:solidFill>
+                  <a:srgbClr val="A9A89F"/>
+                </a:solidFill>
+                <a:latin typeface="PingFang SC"/>
+              </a:rPr>
+              <a:t>• 从 SDF 时序仿真到门级功耗估计</a:t>
+            </a:r>
+          </a:p>
+        </p:txBody>
+      </p:sp>
+    </p:spTree>
+  </p:cSld>
+  <p:clrMapOvr>
+    <a:masterClrMapping/>
+  </p:clrMapOvr>
+</p:sld>
+</file>
+
+<file path=ppt/slides/slide18.xml><?xml version="1.0" encoding="utf-8"?>
+<p:sld xmlns:a="http://schemas.openxmlformats.org/drawingml/2006/main" xmlns:p="http://schemas.openxmlformats.org/presentationml/2006/main" xmlns:r="http://schemas.openxmlformats.org/officeDocument/2006/relationships">
+  <p:cSld>
+    <p:bg>
+      <p:bgPr>
+        <a:solidFill>
+          <a:srgbClr val="0E0E0D"/>
+        </a:solidFill>
+        <a:effectLst/>
+      </p:bgPr>
+    </p:bg>
+    <p:spTree>
+      <p:nvGrpSpPr>
+        <p:cNvPr id="1" name=""/>
+        <p:cNvGrpSpPr/>
+        <p:nvPr/>
+      </p:nvGrpSpPr>
+      <p:grpSpPr/>
+      <p:sp>
+        <p:nvSpPr>
+          <p:cNvPr id="2" name="TextBox 1"/>
+          <p:cNvSpPr txBox="1"/>
+          <p:nvPr/>
+        </p:nvSpPr>
+        <p:spPr>
+          <a:xfrm>
             <a:off x="822960" y="1828800"/>
             <a:ext cx="10515600" cy="1097280"/>
           </a:xfrm>
@@ -12840,7 +13632,7 @@
                 </a:solidFill>
                 <a:latin typeface="PingFang SC"/>
               </a:rPr>
-              <a:t>• 7 类生成器（matmul、FIR、conv2d、FIR 级联、CORDIC、FFT、通用 IR 图）× 5 种器件，20+ 个真实任务达标，最高 319.5 MHz</a:t>
+              <a:t>• 10 类生成器 + 自带 RTL × 6 种后端（含 sky130 ASIC），真实器件上签核；最高 319.5 MHz</a:t>
             </a:r>
           </a:p>
           <a:p>
@@ -12856,7 +13648,7 @@
                 </a:solidFill>
                 <a:latin typeface="PingFang SC"/>
               </a:rPr>
-              <a:t>• 五级仿真阶梯 + 真实布局布线签核 + 3 种子中位数 Fmax + SymbiYosys 形式等价，没有一个估算数字进结论</a:t>
+              <a:t>• 五级仿真阶梯 + 形式等价 + 变异分数：没有一个估算数字进结论</a:t>
             </a:r>
           </a:p>
           <a:p>
@@ -12872,7 +13664,7 @@
                 </a:solidFill>
                 <a:latin typeface="PingFang SC"/>
               </a:rPr>
-              <a:t>• 自动验证的设计经验池；14 例回归每晚自动跑并告警；交付包含 AXI-Stream 包装与板级工程</a:t>
+              <a:t>• 智能体跑在 Agnes Harness 上，并且能在门禁下改自己的生成器——两个旋钮已经由它提出、实测、合并</a:t>
             </a:r>
           </a:p>
           <a:p>
@@ -12888,7 +13680,7 @@
                 </a:solidFill>
                 <a:latin typeface="PingFang SC"/>
               </a:rPr>
-              <a:t>• 3 天、约 9,610 行 Python/JS，38 次提交；已部署，笔记本是瘦客户端</a:t>
+              <a:t>• 每晚回归；交付包含 AXI-Stream 包装、板级工程、ASIC 的 GDS；MCP 服务器给别的智能体用</a:t>
             </a:r>
           </a:p>
         </p:txBody>

</xml_diff>